<commit_message>
Separate the two scores, and write the script down
The audit found one factual error. B1 said marketability is computed on
eight weighted components. It is not: marketability is the mean of five
computed dimensions, which is what the product's own dashboard says on
its face. The eight weighted components are the sponsor-match score,
which needs a campaign to exist at all. Step 02 now says five, step 03
says eight, and the two are no longer the same sentence.

The presentation title carried an em-dash into the file properties.

SCRIPT.md is the spoken version of all nineteen presented slides with a
target for each, a cumulative clock, the three checkpoints, what to cut
if the clock goes, and the eight questions that have a backup slide plus
the four that do not.

Co-Authored-By: Claude Opus 5 <noreply@anthropic.com>
Claude-Session: https://claude.ai/code/session_01UkTWBRwJv9k9Gytr2qrghD
</commit_message>
<xml_diff>
--- a/deck/Stride_Pitch_Deck.pptx
+++ b/deck/Stride_Pitch_Deck.pptx
@@ -144,12 +144,12 @@
   <p:extLst>
     <p:ext uri="{521415D9-36F7-43E2-AB2F-B90AF26B5E84}">
       <p14:sectionLst xmlns:p14="http://schemas.microsoft.com/office/powerpoint/2010/main">
-        <p14:section name="Open" id="{CD08F9EE-7D89-EB90-7B28-EB1EB90D6315}">
+        <p14:section name="Open" id="{F983554B-14D7-D713-F8DE-01828A4CAD28}">
           <p14:sldIdLst>
             <p14:sldId id="256"/>
           </p14:sldIdLst>
         </p14:section>
-        <p14:section name="Problem" id="{FC9FFA67-BC23-D3A2-59AD-E50693360312}">
+        <p14:section name="Problem" id="{7E6A7A9A-58E7-23E2-2BE5-88D1FD59D967}">
           <p14:sldIdLst>
             <p14:sldId id="257"/>
             <p14:sldId id="258"/>
@@ -157,7 +157,7 @@
             <p14:sldId id="260"/>
           </p14:sldIdLst>
         </p14:section>
-        <p14:section name="Product" id="{677D4C7C-3112-4E1D-B099-5E8E4EDCBC9A}">
+        <p14:section name="Product" id="{6811445A-18E1-01DC-A763-C61A0D822916}">
           <p14:sldIdLst>
             <p14:sldId id="261"/>
             <p14:sldId id="262"/>
@@ -166,28 +166,28 @@
             <p14:sldId id="265"/>
           </p14:sldIdLst>
         </p14:section>
-        <p14:section name="Market" id="{7B2D62DE-2F5F-678E-B6BF-DBDA0B5C5BE8}">
+        <p14:section name="Market" id="{43CF304B-6CBE-8DC4-9F83-8553E006F26E}">
           <p14:sldIdLst>
             <p14:sldId id="266"/>
             <p14:sldId id="267"/>
             <p14:sldId id="268"/>
           </p14:sldIdLst>
         </p14:section>
-        <p14:section name="Model" id="{0642DDA1-F9D0-468C-7DAB-BED1FFEB5A4A}">
+        <p14:section name="Model" id="{FE3BAB5A-77CE-4FDE-5016-8E0B853E5967}">
           <p14:sldIdLst>
             <p14:sldId id="269"/>
             <p14:sldId id="270"/>
             <p14:sldId id="271"/>
           </p14:sldIdLst>
         </p14:section>
-        <p14:section name="Money" id="{184CE615-67D4-F60C-6B1D-9AA9ADDBF203}">
+        <p14:section name="Money" id="{3F4C3298-2F95-D7E3-79E8-C70567DAD001}">
           <p14:sldIdLst>
             <p14:sldId id="272"/>
             <p14:sldId id="273"/>
             <p14:sldId id="274"/>
           </p14:sldIdLst>
         </p14:section>
-        <p14:section name="Backup" id="{99A84D8B-1478-BB4B-4261-CE2EBD853586}">
+        <p14:section name="Backup" id="{C93D6AE7-376A-5425-14D9-4019581D5FFD}">
           <p14:sldIdLst>
             <p14:sldId id="275"/>
             <p14:sldId id="276"/>
@@ -305,7 +305,7 @@
           </c:val>
           <c:extLst>
             <c:ext xmlns:c16="http://schemas.microsoft.com/office/drawing/2014/chart" uri="{C3380CC4-5D6E-409C-BE32-E72D297353CC}">
-              <c16:uniqueId val="{00000000-C872-439F-9B67-8AED45576E05}"/>
+              <c16:uniqueId val="{00000000-7372-4295-A273-9D0DD392BB3B}"/>
             </c:ext>
           </c:extLst>
         </c:ser>
@@ -391,7 +391,7 @@
           </c:val>
           <c:extLst>
             <c:ext xmlns:c16="http://schemas.microsoft.com/office/drawing/2014/chart" uri="{C3380CC4-5D6E-409C-BE32-E72D297353CC}">
-              <c16:uniqueId val="{00000001-C872-439F-9B67-8AED45576E05}"/>
+              <c16:uniqueId val="{00000001-7372-4295-A273-9D0DD392BB3B}"/>
             </c:ext>
           </c:extLst>
         </c:ser>
@@ -477,7 +477,7 @@
           </c:val>
           <c:extLst>
             <c:ext xmlns:c16="http://schemas.microsoft.com/office/drawing/2014/chart" uri="{C3380CC4-5D6E-409C-BE32-E72D297353CC}">
-              <c16:uniqueId val="{00000002-C872-439F-9B67-8AED45576E05}"/>
+              <c16:uniqueId val="{00000002-7372-4295-A273-9D0DD392BB3B}"/>
             </c:ext>
           </c:extLst>
         </c:ser>
@@ -735,7 +735,7 @@
           </c:val>
           <c:extLst>
             <c:ext xmlns:c16="http://schemas.microsoft.com/office/drawing/2014/chart" uri="{C3380CC4-5D6E-409C-BE32-E72D297353CC}">
-              <c16:uniqueId val="{00000000-81C4-49FD-99E4-C93C88FF857D}"/>
+              <c16:uniqueId val="{00000000-C8B5-4CD5-983D-3A184105E894}"/>
             </c:ext>
           </c:extLst>
         </c:ser>
@@ -857,7 +857,7 @@
           <c:smooth val="0"/>
           <c:extLst>
             <c:ext xmlns:c16="http://schemas.microsoft.com/office/drawing/2014/chart" uri="{C3380CC4-5D6E-409C-BE32-E72D297353CC}">
-              <c16:uniqueId val="{00000001-81C4-49FD-99E4-C93C88FF857D}"/>
+              <c16:uniqueId val="{00000001-C8B5-4CD5-983D-3A184105E894}"/>
             </c:ext>
           </c:extLst>
         </c:ser>
@@ -1133,7 +1133,7 @@
           <c:smooth val="0"/>
           <c:extLst>
             <c:ext xmlns:c16="http://schemas.microsoft.com/office/drawing/2014/chart" uri="{C3380CC4-5D6E-409C-BE32-E72D297353CC}">
-              <c16:uniqueId val="{00000000-C0DA-45A6-A95C-A304A0156097}"/>
+              <c16:uniqueId val="{00000000-B442-43EF-AA5D-0EEDB7B0E613}"/>
             </c:ext>
           </c:extLst>
         </c:ser>
@@ -1298,7 +1298,7 @@
     </p:spTree>
     <p:extLst>
       <p:ext uri="{BB962C8B-B14F-4D97-AF65-F5344CB8AC3E}">
-        <p14:creationId xmlns:p14="http://schemas.microsoft.com/office/powerpoint/2010/main" val="4069615097"/>
+        <p14:creationId xmlns:p14="http://schemas.microsoft.com/office/powerpoint/2010/main" val="3982140233"/>
       </p:ext>
     </p:extLst>
   </p:cSld>
@@ -14363,7 +14363,7 @@
                 <a:ea typeface="Barlow" pitchFamily="34" charset="-122"/>
                 <a:cs typeface="Barlow" pitchFamily="34" charset="-120"/>
               </a:rPr>
-              <a:t>Marketability is computed on eight weighted components, each traceable to the posts behind it, and every score version is kept.</a:t>
+              <a:t>Marketability is the mean of five computed dimensions, each traceable to the posts behind it, and every score version is kept.</a:t>
             </a:r>
             <a:endParaRPr lang="en-US" sz="1250" dirty="0"/>
           </a:p>
@@ -14510,7 +14510,7 @@
                 <a:ea typeface="Barlow" pitchFamily="34" charset="-122"/>
                 <a:cs typeface="Barlow" pitchFamily="34" charset="-120"/>
               </a:rPr>
-              <a:t>A sponsor briefs a campaign and receives a ranked shortlist in which every score decomposes: audience fit 72 × 32% = 23.1.</a:t>
+              <a:t>A sponsor briefs a campaign, and the match is scored on eight weighted components, each one decomposed: audience fit 72 × 32% = 23.1.</a:t>
             </a:r>
             <a:endParaRPr lang="en-US" sz="1250" dirty="0"/>
           </a:p>

</xml_diff>

<commit_message>
Put the scope above the number, not below it
Reading order was the number, then what it measured, then a card
conceding that one of the five has a sponsor. For anyone who does not
read the label, the slide appears to contradict itself inside two
inches. The stat helper in this deck already puts a tracked cap label
over its numeral, so label-first is the house convention anyway and this
slide was the one place breaking it.

Also drops a hedging line I had added under the figure. The scope now
sits in the label where it belongs, and the euro question goes in the
notes rather than onto the slide: the plan is euro denominated and Spain
is the launch market, and zero is the one figure whose unit cannot
change the answer.

Co-Authored-By: Claude Opus 5 <noreply@anthropic.com>
Claude-Session: https://claude.ai/code/session_01UkTWBRwJv9k9Gytr2qrghD
</commit_message>
<xml_diff>
--- a/deck/Stride_Pitch_Deck.pptx
+++ b/deck/Stride_Pitch_Deck.pptx
@@ -144,12 +144,12 @@
   <p:extLst>
     <p:ext uri="{521415D9-36F7-43E2-AB2F-B90AF26B5E84}">
       <p14:sectionLst xmlns:p14="http://schemas.microsoft.com/office/powerpoint/2010/main">
-        <p14:section name="Open" id="{7B71D9B7-8105-7CA0-E67A-C695B3877B6D}">
+        <p14:section name="Open" id="{0434A21F-CC77-C284-163D-286B411C53CC}">
           <p14:sldIdLst>
             <p14:sldId id="256"/>
           </p14:sldIdLst>
         </p14:section>
-        <p14:section name="Problem" id="{5D9C4B10-045C-4BF0-32AA-7C127C3E42BA}">
+        <p14:section name="Problem" id="{8F2DBDBA-E065-6E13-0118-8D08905AF80B}">
           <p14:sldIdLst>
             <p14:sldId id="257"/>
             <p14:sldId id="258"/>
@@ -157,7 +157,7 @@
             <p14:sldId id="260"/>
           </p14:sldIdLst>
         </p14:section>
-        <p14:section name="Product" id="{448C143E-D4D8-B66C-1F5D-62839D0D49E5}">
+        <p14:section name="Product" id="{A9DC15EC-B0B4-DF0B-CA17-2652BAB783EE}">
           <p14:sldIdLst>
             <p14:sldId id="261"/>
             <p14:sldId id="262"/>
@@ -166,28 +166,28 @@
             <p14:sldId id="265"/>
           </p14:sldIdLst>
         </p14:section>
-        <p14:section name="Market" id="{7652C5EF-CD0F-81BE-7E1B-90C87DBC1350}">
+        <p14:section name="Market" id="{56C381A4-CFF0-8467-9280-E084A20B1BA0}">
           <p14:sldIdLst>
             <p14:sldId id="266"/>
             <p14:sldId id="267"/>
             <p14:sldId id="268"/>
           </p14:sldIdLst>
         </p14:section>
-        <p14:section name="Model" id="{EAA52762-882A-67AF-0000-E973364286DD}">
+        <p14:section name="Model" id="{EB9E722F-DDEB-7B79-E30C-917CF435CBB5}">
           <p14:sldIdLst>
             <p14:sldId id="269"/>
             <p14:sldId id="270"/>
             <p14:sldId id="271"/>
           </p14:sldIdLst>
         </p14:section>
-        <p14:section name="Money" id="{69F4CEBC-0298-7282-A060-562652D724A6}">
+        <p14:section name="Money" id="{CF85A7D2-B9B7-93CD-7A0D-2072A92B5B08}">
           <p14:sldIdLst>
             <p14:sldId id="272"/>
             <p14:sldId id="273"/>
             <p14:sldId id="274"/>
           </p14:sldIdLst>
         </p14:section>
-        <p14:section name="Backup" id="{B96E8C73-C6C4-28C8-1ACB-8EF1AFF4361B}">
+        <p14:section name="Backup" id="{63A7A871-0727-CA89-391E-DF12C1E0F5DA}">
           <p14:sldIdLst>
             <p14:sldId id="275"/>
             <p14:sldId id="276"/>
@@ -305,7 +305,7 @@
           </c:val>
           <c:extLst>
             <c:ext xmlns:c16="http://schemas.microsoft.com/office/drawing/2014/chart" uri="{C3380CC4-5D6E-409C-BE32-E72D297353CC}">
-              <c16:uniqueId val="{00000000-C3D3-476F-98CB-4975062C4831}"/>
+              <c16:uniqueId val="{00000000-5FF6-441A-B64C-DEC951995098}"/>
             </c:ext>
           </c:extLst>
         </c:ser>
@@ -391,7 +391,7 @@
           </c:val>
           <c:extLst>
             <c:ext xmlns:c16="http://schemas.microsoft.com/office/drawing/2014/chart" uri="{C3380CC4-5D6E-409C-BE32-E72D297353CC}">
-              <c16:uniqueId val="{00000001-C3D3-476F-98CB-4975062C4831}"/>
+              <c16:uniqueId val="{00000001-5FF6-441A-B64C-DEC951995098}"/>
             </c:ext>
           </c:extLst>
         </c:ser>
@@ -477,7 +477,7 @@
           </c:val>
           <c:extLst>
             <c:ext xmlns:c16="http://schemas.microsoft.com/office/drawing/2014/chart" uri="{C3380CC4-5D6E-409C-BE32-E72D297353CC}">
-              <c16:uniqueId val="{00000002-C3D3-476F-98CB-4975062C4831}"/>
+              <c16:uniqueId val="{00000002-5FF6-441A-B64C-DEC951995098}"/>
             </c:ext>
           </c:extLst>
         </c:ser>
@@ -735,7 +735,7 @@
           </c:val>
           <c:extLst>
             <c:ext xmlns:c16="http://schemas.microsoft.com/office/drawing/2014/chart" uri="{C3380CC4-5D6E-409C-BE32-E72D297353CC}">
-              <c16:uniqueId val="{00000000-2C35-46CE-A62A-71653A582E39}"/>
+              <c16:uniqueId val="{00000000-B52A-42B7-A924-7E2D618A38D2}"/>
             </c:ext>
           </c:extLst>
         </c:ser>
@@ -857,7 +857,7 @@
           <c:smooth val="0"/>
           <c:extLst>
             <c:ext xmlns:c16="http://schemas.microsoft.com/office/drawing/2014/chart" uri="{C3380CC4-5D6E-409C-BE32-E72D297353CC}">
-              <c16:uniqueId val="{00000001-2C35-46CE-A62A-71653A582E39}"/>
+              <c16:uniqueId val="{00000001-B52A-42B7-A924-7E2D618A38D2}"/>
             </c:ext>
           </c:extLst>
         </c:ser>
@@ -1133,7 +1133,7 @@
           <c:smooth val="0"/>
           <c:extLst>
             <c:ext xmlns:c16="http://schemas.microsoft.com/office/drawing/2014/chart" uri="{C3380CC4-5D6E-409C-BE32-E72D297353CC}">
-              <c16:uniqueId val="{00000000-BF9F-4106-A6D8-032D45469F70}"/>
+              <c16:uniqueId val="{00000000-8AA4-4047-AE02-7901A5C50CF9}"/>
             </c:ext>
           </c:extLst>
         </c:ser>
@@ -1298,7 +1298,7 @@
     </p:spTree>
     <p:extLst>
       <p:ext uri="{BB962C8B-B14F-4D97-AF65-F5344CB8AC3E}">
-        <p14:creationId xmlns:p14="http://schemas.microsoft.com/office/powerpoint/2010/main" val="268650731"/>
+        <p14:creationId xmlns:p14="http://schemas.microsoft.com/office/powerpoint/2010/main" val="3575168175"/>
       </p:ext>
     </p:extLst>
   </p:cSld>
@@ -3292,7 +3292,8 @@
               <a:t>He was one of five athletes in my own sports I asked the same question: what has your sport ever paid you.
 The answer was not 'a little'. Across all five it is zero, and I want to be precise about what that zero is, because one of them does have a sponsor.
 He did not get it as a rugby league player. It came to him some other way, and no part of it came through the sport. So the claim is not that these people are uncommercial. A brand pays him. The claim is that the sport captures none of it, because there is no route by which it could. That is a stronger finding than five zeros would have been.
-And read the quote, because it is the one that matters most: they do not build an audience, because there is no return on building one. That is not a complaint about pricing. It is a market with no infrastructure in it.</a:t>
+And read the quote, because it is the one that matters most: they do not build an audience, because there is no return on building one. That is not a complaint about pricing. It is a market with no infrastructure in it.
+If anyone asks why the figure is in euros when two of the three sports are in Lebanon: the whole plan is denominated in euros and Spain is the launch market, so it is the unit every other number in this deck uses. Zero is the one figure where the unit cannot change the answer.</a:t>
             </a:r>
           </a:p>
         </p:txBody>
@@ -22004,7 +22005,46 @@
         </p:nvSpPr>
         <p:spPr>
           <a:xfrm>
-            <a:off x="713232" y="1143000"/>
+            <a:off x="713232" y="1005840"/>
+            <a:ext cx="5120640" cy="274320"/>
+          </a:xfrm>
+          <a:prstGeom prst="rect">
+            <a:avLst/>
+          </a:prstGeom>
+          <a:noFill/>
+          <a:ln/>
+        </p:spPr>
+        <p:txBody>
+          <a:bodyPr wrap="square" lIns="0" tIns="0" rIns="0" bIns="0" rtlCol="0" anchor="t"/>
+          <a:lstStyle/>
+          <a:p>
+            <a:pPr marL="0" indent="0">
+              <a:buNone/>
+            </a:pPr>
+            <a:r>
+              <a:rPr lang="en-US" sz="1300" kern="0" spc="260" dirty="0">
+                <a:solidFill>
+                  <a:srgbClr val="828C9A"/>
+                </a:solidFill>
+                <a:latin typeface="Barlow Condensed" pitchFamily="34" charset="0"/>
+                <a:ea typeface="Barlow Condensed" pitchFamily="34" charset="-122"/>
+                <a:cs typeface="Barlow Condensed" pitchFamily="34" charset="-120"/>
+              </a:rPr>
+              <a:t>INCOME THE SPORT ITSELF PRODUCED</a:t>
+            </a:r>
+            <a:endParaRPr lang="en-US" sz="1300" dirty="0"/>
+          </a:p>
+        </p:txBody>
+      </p:sp>
+      <p:sp>
+        <p:nvSpPr>
+          <p:cNvPr id="4" name="Text 2"/>
+          <p:cNvSpPr txBox="1"/>
+          <p:nvPr/>
+        </p:nvSpPr>
+        <p:spPr>
+          <a:xfrm>
+            <a:off x="713232" y="1353312"/>
             <a:ext cx="4754880" cy="2286000"/>
           </a:xfrm>
           <a:prstGeom prst="rect">
@@ -22040,79 +22080,40 @@
       </p:sp>
       <p:sp>
         <p:nvSpPr>
-          <p:cNvPr id="4" name="Text 2"/>
-          <p:cNvSpPr txBox="1"/>
-          <p:nvPr/>
-        </p:nvSpPr>
-        <p:spPr>
-          <a:xfrm>
-            <a:off x="713232" y="3310128"/>
-            <a:ext cx="5120640" cy="274320"/>
-          </a:xfrm>
-          <a:prstGeom prst="rect">
-            <a:avLst/>
-          </a:prstGeom>
-          <a:noFill/>
-          <a:ln/>
-        </p:spPr>
-        <p:txBody>
-          <a:bodyPr wrap="square" lIns="0" tIns="0" rIns="0" bIns="0" rtlCol="0" anchor="t"/>
-          <a:lstStyle/>
-          <a:p>
-            <a:pPr marL="0" indent="0">
-              <a:buNone/>
-            </a:pPr>
-            <a:r>
-              <a:rPr lang="en-US" sz="1300" kern="0" spc="260" dirty="0">
-                <a:solidFill>
-                  <a:srgbClr val="828C9A"/>
+          <p:cNvPr id="5" name="Text 3"/>
+          <p:cNvSpPr txBox="1"/>
+          <p:nvPr/>
+        </p:nvSpPr>
+        <p:spPr>
+          <a:xfrm>
+            <a:off x="713232" y="3255264"/>
+            <a:ext cx="5120640" cy="822960"/>
+          </a:xfrm>
+          <a:prstGeom prst="rect">
+            <a:avLst/>
+          </a:prstGeom>
+          <a:noFill/>
+          <a:ln/>
+        </p:spPr>
+        <p:txBody>
+          <a:bodyPr wrap="square" lIns="0" tIns="0" rIns="0" bIns="0" rtlCol="0" anchor="t"/>
+          <a:lstStyle/>
+          <a:p>
+            <a:pPr marL="0" indent="0">
+              <a:lnSpc>
+                <a:spcPts val="3400"/>
+              </a:lnSpc>
+              <a:buNone/>
+            </a:pPr>
+            <a:r>
+              <a:rPr lang="en-US" sz="3000" dirty="0">
+                <a:solidFill>
+                  <a:srgbClr val="FFB020"/>
                 </a:solidFill>
                 <a:latin typeface="Barlow Condensed" pitchFamily="34" charset="0"/>
                 <a:ea typeface="Barlow Condensed" pitchFamily="34" charset="-122"/>
                 <a:cs typeface="Barlow Condensed" pitchFamily="34" charset="-120"/>
               </a:rPr>
-              <a:t>INCOME THE SPORT ITSELF PRODUCED</a:t>
-            </a:r>
-            <a:endParaRPr lang="en-US" sz="1300" dirty="0"/>
-          </a:p>
-        </p:txBody>
-      </p:sp>
-      <p:sp>
-        <p:nvSpPr>
-          <p:cNvPr id="5" name="Text 3"/>
-          <p:cNvSpPr txBox="1"/>
-          <p:nvPr/>
-        </p:nvSpPr>
-        <p:spPr>
-          <a:xfrm>
-            <a:off x="713232" y="3703320"/>
-            <a:ext cx="5120640" cy="822960"/>
-          </a:xfrm>
-          <a:prstGeom prst="rect">
-            <a:avLst/>
-          </a:prstGeom>
-          <a:noFill/>
-          <a:ln/>
-        </p:spPr>
-        <p:txBody>
-          <a:bodyPr wrap="square" lIns="0" tIns="0" rIns="0" bIns="0" rtlCol="0" anchor="t"/>
-          <a:lstStyle/>
-          <a:p>
-            <a:pPr marL="0" indent="0">
-              <a:lnSpc>
-                <a:spcPts val="3400"/>
-              </a:lnSpc>
-              <a:buNone/>
-            </a:pPr>
-            <a:r>
-              <a:rPr lang="en-US" sz="3000" dirty="0">
-                <a:solidFill>
-                  <a:srgbClr val="FFB020"/>
-                </a:solidFill>
-                <a:latin typeface="Barlow Condensed" pitchFamily="34" charset="0"/>
-                <a:ea typeface="Barlow Condensed" pitchFamily="34" charset="-122"/>
-                <a:cs typeface="Barlow Condensed" pitchFamily="34" charset="-120"/>
-              </a:rPr>
               <a:t>Not low. Not inconsistent. Nothing</a:t>
             </a:r>
             <a:endParaRPr lang="en-US" sz="3000" dirty="0"/>
@@ -22127,7 +22128,7 @@
         </p:nvSpPr>
         <p:spPr>
           <a:xfrm>
-            <a:off x="713232" y="4261104"/>
+            <a:off x="713232" y="3968496"/>
             <a:ext cx="5212080" cy="859536"/>
           </a:xfrm>
           <a:prstGeom prst="roundRect">
@@ -22154,7 +22155,7 @@
         </p:nvSpPr>
         <p:spPr>
           <a:xfrm>
-            <a:off x="969264" y="4425696"/>
+            <a:off x="969264" y="4133088"/>
             <a:ext cx="4754880" cy="219456"/>
           </a:xfrm>
           <a:prstGeom prst="rect">
@@ -22193,7 +22194,7 @@
         </p:nvSpPr>
         <p:spPr>
           <a:xfrm>
-            <a:off x="969264" y="4663440"/>
+            <a:off x="969264" y="4370832"/>
             <a:ext cx="4754880" cy="402336"/>
           </a:xfrm>
           <a:prstGeom prst="rect">

</xml_diff>

<commit_message>
Close the gap the decluttering opened on slide 3
Removing the punch line and the source line left a band of dead space
across the middle of the slide, between the attribution and the two
findings. Raising the findings band to 5.30 moves that air to the foot,
where it reads as margin rather than as something missing. Slide 4's
removal already left its space at the bottom, so it needed nothing.

Nothing is added back. This is the deletion finished rather than
reconsidered.

Co-Authored-By: Claude Opus 5 <noreply@anthropic.com>
Claude-Session: https://claude.ai/code/session_01UkTWBRwJv9k9Gytr2qrghD
</commit_message>
<xml_diff>
--- a/deck/Stride_Pitch_Deck.pptx
+++ b/deck/Stride_Pitch_Deck.pptx
@@ -144,12 +144,12 @@
   <p:extLst>
     <p:ext uri="{521415D9-36F7-43E2-AB2F-B90AF26B5E84}">
       <p14:sectionLst xmlns:p14="http://schemas.microsoft.com/office/powerpoint/2010/main">
-        <p14:section name="Open" id="{7BD90A15-5476-423F-5999-B4ACCB5F45F8}">
+        <p14:section name="Open" id="{6132153C-F8D3-057C-1E9A-3E723B0DA3C1}">
           <p14:sldIdLst>
             <p14:sldId id="256"/>
           </p14:sldIdLst>
         </p14:section>
-        <p14:section name="Problem" id="{82F5BD53-96AB-F7E7-E4E7-9894A09CFB36}">
+        <p14:section name="Problem" id="{930821ED-BA93-5DB7-FDFB-6E085406396C}">
           <p14:sldIdLst>
             <p14:sldId id="257"/>
             <p14:sldId id="258"/>
@@ -157,7 +157,7 @@
             <p14:sldId id="260"/>
           </p14:sldIdLst>
         </p14:section>
-        <p14:section name="Product" id="{B5D138D9-E363-22E4-4D96-8BB874C40B63}">
+        <p14:section name="Product" id="{D36DBB39-2387-51E4-4FBC-CC942A31B4B5}">
           <p14:sldIdLst>
             <p14:sldId id="261"/>
             <p14:sldId id="262"/>
@@ -166,28 +166,28 @@
             <p14:sldId id="265"/>
           </p14:sldIdLst>
         </p14:section>
-        <p14:section name="Market" id="{BC0FC328-1831-9DED-3241-3A4417D4A76E}">
+        <p14:section name="Market" id="{9B213108-67C2-060E-DF52-1141BC09E091}">
           <p14:sldIdLst>
             <p14:sldId id="266"/>
             <p14:sldId id="267"/>
             <p14:sldId id="268"/>
           </p14:sldIdLst>
         </p14:section>
-        <p14:section name="Model" id="{C87CA469-F79E-097E-77A4-09E0A22C4C48}">
+        <p14:section name="Model" id="{B80E22E8-480D-9025-482D-FE4E14A0E28B}">
           <p14:sldIdLst>
             <p14:sldId id="269"/>
             <p14:sldId id="270"/>
             <p14:sldId id="271"/>
           </p14:sldIdLst>
         </p14:section>
-        <p14:section name="Money" id="{3DB96A5D-C476-D2A1-BE0A-2A931652FB1F}">
+        <p14:section name="Money" id="{F3C5F64C-FA9C-C533-C9CE-DA2D8D5EF563}">
           <p14:sldIdLst>
             <p14:sldId id="272"/>
             <p14:sldId id="273"/>
             <p14:sldId id="274"/>
           </p14:sldIdLst>
         </p14:section>
-        <p14:section name="Backup" id="{78458866-2A9C-720C-8E4C-ECBE97AE5264}">
+        <p14:section name="Backup" id="{83794092-2096-6712-30FE-A5C160B859E6}">
           <p14:sldIdLst>
             <p14:sldId id="275"/>
             <p14:sldId id="276"/>
@@ -305,7 +305,7 @@
           </c:val>
           <c:extLst>
             <c:ext xmlns:c16="http://schemas.microsoft.com/office/drawing/2014/chart" uri="{C3380CC4-5D6E-409C-BE32-E72D297353CC}">
-              <c16:uniqueId val="{00000000-9808-4265-88D9-07E975753731}"/>
+              <c16:uniqueId val="{00000000-9BA9-47AC-91D1-82E534479A8F}"/>
             </c:ext>
           </c:extLst>
         </c:ser>
@@ -391,7 +391,7 @@
           </c:val>
           <c:extLst>
             <c:ext xmlns:c16="http://schemas.microsoft.com/office/drawing/2014/chart" uri="{C3380CC4-5D6E-409C-BE32-E72D297353CC}">
-              <c16:uniqueId val="{00000001-9808-4265-88D9-07E975753731}"/>
+              <c16:uniqueId val="{00000001-9BA9-47AC-91D1-82E534479A8F}"/>
             </c:ext>
           </c:extLst>
         </c:ser>
@@ -477,7 +477,7 @@
           </c:val>
           <c:extLst>
             <c:ext xmlns:c16="http://schemas.microsoft.com/office/drawing/2014/chart" uri="{C3380CC4-5D6E-409C-BE32-E72D297353CC}">
-              <c16:uniqueId val="{00000002-9808-4265-88D9-07E975753731}"/>
+              <c16:uniqueId val="{00000002-9BA9-47AC-91D1-82E534479A8F}"/>
             </c:ext>
           </c:extLst>
         </c:ser>
@@ -735,7 +735,7 @@
           </c:val>
           <c:extLst>
             <c:ext xmlns:c16="http://schemas.microsoft.com/office/drawing/2014/chart" uri="{C3380CC4-5D6E-409C-BE32-E72D297353CC}">
-              <c16:uniqueId val="{00000000-BC0E-47EF-BC14-9F4FBF81607D}"/>
+              <c16:uniqueId val="{00000000-829C-4666-9FD6-56D394CBFBE9}"/>
             </c:ext>
           </c:extLst>
         </c:ser>
@@ -857,7 +857,7 @@
           <c:smooth val="0"/>
           <c:extLst>
             <c:ext xmlns:c16="http://schemas.microsoft.com/office/drawing/2014/chart" uri="{C3380CC4-5D6E-409C-BE32-E72D297353CC}">
-              <c16:uniqueId val="{00000001-BC0E-47EF-BC14-9F4FBF81607D}"/>
+              <c16:uniqueId val="{00000001-829C-4666-9FD6-56D394CBFBE9}"/>
             </c:ext>
           </c:extLst>
         </c:ser>
@@ -1133,7 +1133,7 @@
           <c:smooth val="0"/>
           <c:extLst>
             <c:ext xmlns:c16="http://schemas.microsoft.com/office/drawing/2014/chart" uri="{C3380CC4-5D6E-409C-BE32-E72D297353CC}">
-              <c16:uniqueId val="{00000000-9DB2-429C-8256-E12B4D766DCD}"/>
+              <c16:uniqueId val="{00000000-FED6-433B-B552-FBD3A2F4F57A}"/>
             </c:ext>
           </c:extLst>
         </c:ser>
@@ -1298,7 +1298,7 @@
     </p:spTree>
     <p:extLst>
       <p:ext uri="{BB962C8B-B14F-4D97-AF65-F5344CB8AC3E}">
-        <p14:creationId xmlns:p14="http://schemas.microsoft.com/office/powerpoint/2010/main" val="3766977319"/>
+        <p14:creationId xmlns:p14="http://schemas.microsoft.com/office/powerpoint/2010/main" val="1694608085"/>
       </p:ext>
     </p:extLst>
   </p:cSld>
@@ -22382,7 +22382,7 @@
         </p:nvSpPr>
         <p:spPr>
           <a:xfrm>
-            <a:off x="713232" y="5248656"/>
+            <a:off x="713232" y="4846320"/>
             <a:ext cx="5245456" cy="12802"/>
           </a:xfrm>
           <a:prstGeom prst="rect">
@@ -22407,7 +22407,7 @@
         </p:nvSpPr>
         <p:spPr>
           <a:xfrm>
-            <a:off x="713232" y="5376672"/>
+            <a:off x="713232" y="4974336"/>
             <a:ext cx="5245456" cy="219456"/>
           </a:xfrm>
           <a:prstGeom prst="rect">
@@ -22446,7 +22446,7 @@
         </p:nvSpPr>
         <p:spPr>
           <a:xfrm>
-            <a:off x="713232" y="5614416"/>
+            <a:off x="713232" y="5212080"/>
             <a:ext cx="5245456" cy="548640"/>
           </a:xfrm>
           <a:prstGeom prst="rect">
@@ -22488,7 +22488,7 @@
         </p:nvSpPr>
         <p:spPr>
           <a:xfrm>
-            <a:off x="6233008" y="5248656"/>
+            <a:off x="6233008" y="4846320"/>
             <a:ext cx="5245456" cy="12802"/>
           </a:xfrm>
           <a:prstGeom prst="rect">
@@ -22513,7 +22513,7 @@
         </p:nvSpPr>
         <p:spPr>
           <a:xfrm>
-            <a:off x="6233008" y="5376672"/>
+            <a:off x="6233008" y="4974336"/>
             <a:ext cx="5245456" cy="219456"/>
           </a:xfrm>
           <a:prstGeom prst="rect">
@@ -22552,7 +22552,7 @@
         </p:nvSpPr>
         <p:spPr>
           <a:xfrm>
-            <a:off x="6233008" y="5614416"/>
+            <a:off x="6233008" y="5212080"/>
             <a:ext cx="5245456" cy="548640"/>
           </a:xfrm>
           <a:prstGeom prst="rect">

</xml_diff>